<commit_message>
Replace slide 25 video with English-language news clip; rebuild APK and decks
Co-Authored-By: Claude Sonnet 5.5 <noreply@anthropic.com>
Claude-Session: https://claude.ai/code/session_01QoBEPxbicZNbtosTbAi2im
</commit_message>
<xml_diff>
--- a/Humanoide_Roboter_Videofolien.pptx
+++ b/Humanoide_Roboter_Videofolien.pptx
@@ -155,7 +155,7 @@
   <p:extLst>
     <p:ext uri="{521415D9-36F7-43E2-AB2F-B90AF26B5E84}">
       <p14:sectionLst xmlns:p14="http://schemas.microsoft.com/office/powerpoint/2010/main">
-        <p14:section name="Teil 1: Geschichte der humanoiden Roboter" id="{1c7e5429-fab2-a4b2-869e-bebc25ae84d4}">
+        <p14:section name="Teil 1: Geschichte der humanoiden Roboter" id="{7f15dea6-5861-bed3-c18f-952dbd1e5fca}">
           <p14:sldIdLst>
             <p14:sldId id="257"/>
             <p14:sldId id="258"/>
@@ -166,7 +166,7 @@
             <p14:sldId id="263"/>
           </p14:sldIdLst>
         </p14:section>
-        <p14:section name="Teil 2: Sport, Athletik und Wettkämpfe" id="{08d7ad08-b4de-d309-bd6b-6418e7ff10ae}">
+        <p14:section name="Teil 2: Sport, Athletik und Wettkämpfe" id="{3b647fa4-8067-3194-b60d-d5b7160c9f3f}">
           <p14:sldIdLst>
             <p14:sldId id="264"/>
             <p14:sldId id="265"/>
@@ -180,7 +180,7 @@
             <p14:sldId id="273"/>
           </p14:sldIdLst>
         </p14:section>
-        <p14:section name="Teil 3: Industrie &amp; Fabriken" id="{694f0416-30d2-3c53-4962-aaceb6e800d7}">
+        <p14:section name="Teil 3: Industrie &amp; Fabriken" id="{16ab76e2-e64e-355f-63e9-a52c75829f4e}">
           <p14:sldIdLst>
             <p14:sldId id="274"/>
             <p14:sldId id="275"/>
@@ -191,7 +191,7 @@
             <p14:sldId id="280"/>
           </p14:sldIdLst>
         </p14:section>
-        <p14:section name="Teil 4: Künstliche Intelligenz &amp; Schlüsseltechnologien" id="{fd76aea3-123b-d1ce-e16a-63280428f8f1}">
+        <p14:section name="Teil 4: Künstliche Intelligenz &amp; Schlüsseltechnologien" id="{ca0f36b2-5748-8fc5-00d2-18995cdc1855}">
           <p14:sldIdLst>
             <p14:sldId id="281"/>
             <p14:sldId id="282"/>
@@ -205,7 +205,7 @@
             <p14:sldId id="290"/>
           </p14:sldIdLst>
         </p14:section>
-        <p14:section name="Teil 5: Haushaltsroboter &amp; Zukunftsprognosen" id="{7f9aca87-1ca4-3137-eed9-318d5adcdf69}">
+        <p14:section name="Teil 5: Haushaltsroboter &amp; Zukunftsprognosen" id="{aff1fec9-1b4b-711a-41e8-a047e5254c1b}">
           <p14:sldIdLst>
             <p14:sldId id="291"/>
             <p14:sldId id="292"/>
@@ -3355,7 +3355,7 @@
           <a:p>
             <a:r>
               <a:rPr lang="en-US" dirty="0"/>
-              <a:t>Bildmotiv: Roboterhände falten ein weißes Handtuch, daneben der kompakte Unitree G1. | Video: https://www.youtube.com/watch?v=Wn2AzxnmxQE (Unitree G1 Home Task Demo). Im Original-Dokument angegeben als: Unitree G1 Home Task Demo</a:t>
+              <a:t>Bildmotiv: Roboterhände falten ein weißes Handtuch, daneben der kompakte Unitree G1. | Video: https://www.youtube.com/watch?v=tckyf12vLE4 (San Francisco company debuts laundry-folding robot (KTVU)). Im Original-Dokument angegeben als: San Francisco company debuts laundry-folding robot (KTVU)</a:t>
             </a:r>
             <a:endParaRPr lang="en-US" dirty="0"/>
           </a:p>
@@ -3443,7 +3443,7 @@
           <a:p>
             <a:r>
               <a:rPr lang="en-US" dirty="0"/>
-              <a:t>Video zu Folie 25: https://www.youtube.com/watch?v=Wn2AzxnmxQE (Unitree G1 Home Task Demo). Falls es nicht abspielt: Link öffnen.</a:t>
+              <a:t>Video zu Folie 25: https://www.youtube.com/watch?v=tckyf12vLE4 (San Francisco company debuts laundry-folding robot (KTVU)). Falls es nicht abspielt: Link öffnen.</a:t>
             </a:r>
             <a:endParaRPr lang="en-US" dirty="0"/>
           </a:p>
@@ -12207,7 +12207,7 @@
                   </a:extLst>
                 </a:hlinkClick>
               </a:rPr>
-              <a:t>Unitree G1 Home Task Demo</a:t>
+              <a:t>San Francisco company debuts laundry-folding robot (KTVU)</a:t>
             </a:r>
             <a:endParaRPr lang="en-US" sz="1300" dirty="0"/>
           </a:p>

</xml_diff>